<commit_message>
* updated pptx presentation
</commit_message>
<xml_diff>
--- a/1-5-bridge/bridge_pattern.pptx
+++ b/1-5-bridge/bridge_pattern.pptx
@@ -208,7 +208,7 @@
           <a:p>
             <a:fld id="{47871E64-B4EF-4B40-B724-CEB241626157}" type="datetimeFigureOut">
               <a:rPr lang="en-US" smtClean="0"/>
-              <a:t>9/14/25</a:t>
+              <a:t>9/16/25</a:t>
             </a:fld>
             <a:endParaRPr lang="en-US"/>
           </a:p>
@@ -706,7 +706,7 @@
           <a:p>
             <a:fld id="{72235F10-9AD9-9C43-8528-A461A66E7819}" type="datetimeFigureOut">
               <a:rPr lang="en-US" smtClean="0"/>
-              <a:t>9/14/25</a:t>
+              <a:t>9/16/25</a:t>
             </a:fld>
             <a:endParaRPr lang="en-US"/>
           </a:p>
@@ -904,7 +904,7 @@
           <a:p>
             <a:fld id="{72235F10-9AD9-9C43-8528-A461A66E7819}" type="datetimeFigureOut">
               <a:rPr lang="en-US" smtClean="0"/>
-              <a:t>9/14/25</a:t>
+              <a:t>9/16/25</a:t>
             </a:fld>
             <a:endParaRPr lang="en-US"/>
           </a:p>
@@ -1112,7 +1112,7 @@
           <a:p>
             <a:fld id="{72235F10-9AD9-9C43-8528-A461A66E7819}" type="datetimeFigureOut">
               <a:rPr lang="en-US" smtClean="0"/>
-              <a:t>9/14/25</a:t>
+              <a:t>9/16/25</a:t>
             </a:fld>
             <a:endParaRPr lang="en-US"/>
           </a:p>
@@ -1310,7 +1310,7 @@
           <a:p>
             <a:fld id="{72235F10-9AD9-9C43-8528-A461A66E7819}" type="datetimeFigureOut">
               <a:rPr lang="en-US" smtClean="0"/>
-              <a:t>9/14/25</a:t>
+              <a:t>9/16/25</a:t>
             </a:fld>
             <a:endParaRPr lang="en-US"/>
           </a:p>
@@ -1585,7 +1585,7 @@
           <a:p>
             <a:fld id="{72235F10-9AD9-9C43-8528-A461A66E7819}" type="datetimeFigureOut">
               <a:rPr lang="en-US" smtClean="0"/>
-              <a:t>9/14/25</a:t>
+              <a:t>9/16/25</a:t>
             </a:fld>
             <a:endParaRPr lang="en-US"/>
           </a:p>
@@ -1850,7 +1850,7 @@
           <a:p>
             <a:fld id="{72235F10-9AD9-9C43-8528-A461A66E7819}" type="datetimeFigureOut">
               <a:rPr lang="en-US" smtClean="0"/>
-              <a:t>9/14/25</a:t>
+              <a:t>9/16/25</a:t>
             </a:fld>
             <a:endParaRPr lang="en-US"/>
           </a:p>
@@ -2262,7 +2262,7 @@
           <a:p>
             <a:fld id="{72235F10-9AD9-9C43-8528-A461A66E7819}" type="datetimeFigureOut">
               <a:rPr lang="en-US" smtClean="0"/>
-              <a:t>9/14/25</a:t>
+              <a:t>9/16/25</a:t>
             </a:fld>
             <a:endParaRPr lang="en-US"/>
           </a:p>
@@ -2403,7 +2403,7 @@
           <a:p>
             <a:fld id="{72235F10-9AD9-9C43-8528-A461A66E7819}" type="datetimeFigureOut">
               <a:rPr lang="en-US" smtClean="0"/>
-              <a:t>9/14/25</a:t>
+              <a:t>9/16/25</a:t>
             </a:fld>
             <a:endParaRPr lang="en-US"/>
           </a:p>
@@ -2516,7 +2516,7 @@
           <a:p>
             <a:fld id="{72235F10-9AD9-9C43-8528-A461A66E7819}" type="datetimeFigureOut">
               <a:rPr lang="en-US" smtClean="0"/>
-              <a:t>9/14/25</a:t>
+              <a:t>9/16/25</a:t>
             </a:fld>
             <a:endParaRPr lang="en-US"/>
           </a:p>
@@ -2827,7 +2827,7 @@
           <a:p>
             <a:fld id="{72235F10-9AD9-9C43-8528-A461A66E7819}" type="datetimeFigureOut">
               <a:rPr lang="en-US" smtClean="0"/>
-              <a:t>9/14/25</a:t>
+              <a:t>9/16/25</a:t>
             </a:fld>
             <a:endParaRPr lang="en-US"/>
           </a:p>
@@ -3115,7 +3115,7 @@
           <a:p>
             <a:fld id="{72235F10-9AD9-9C43-8528-A461A66E7819}" type="datetimeFigureOut">
               <a:rPr lang="en-US" smtClean="0"/>
-              <a:t>9/14/25</a:t>
+              <a:t>9/16/25</a:t>
             </a:fld>
             <a:endParaRPr lang="en-US"/>
           </a:p>
@@ -3356,7 +3356,7 @@
           <a:p>
             <a:fld id="{72235F10-9AD9-9C43-8528-A461A66E7819}" type="datetimeFigureOut">
               <a:rPr lang="en-US" smtClean="0"/>
-              <a:t>9/14/25</a:t>
+              <a:t>9/16/25</a:t>
             </a:fld>
             <a:endParaRPr lang="en-US"/>
           </a:p>
@@ -5458,6 +5458,36 @@
           </a:p>
         </p:txBody>
       </p:sp>
+      <p:pic>
+        <p:nvPicPr>
+          <p:cNvPr id="2" name="Picture 1" descr="A yellow and green corner&#10;&#10;Description automatically generated">
+            <a:extLst>
+              <a:ext uri="{FF2B5EF4-FFF2-40B4-BE49-F238E27FC236}">
+                <a16:creationId xmlns:a16="http://schemas.microsoft.com/office/drawing/2014/main" id="{F3193343-BBEC-CFA9-C99C-9975A33CA8DE}"/>
+              </a:ext>
+            </a:extLst>
+          </p:cNvPr>
+          <p:cNvPicPr>
+            <a:picLocks noChangeAspect="1"/>
+          </p:cNvPicPr>
+          <p:nvPr/>
+        </p:nvPicPr>
+        <p:blipFill>
+          <a:blip r:embed="rId3"/>
+          <a:stretch>
+            <a:fillRect/>
+          </a:stretch>
+        </p:blipFill>
+        <p:spPr>
+          <a:xfrm>
+            <a:off x="11656911" y="6327267"/>
+            <a:ext cx="436029" cy="442697"/>
+          </a:xfrm>
+          <a:prstGeom prst="rect">
+            <a:avLst/>
+          </a:prstGeom>
+        </p:spPr>
+      </p:pic>
     </p:spTree>
     <p:extLst>
       <p:ext uri="{BB962C8B-B14F-4D97-AF65-F5344CB8AC3E}">
@@ -7525,6 +7555,66 @@
           </a:prstGeom>
         </p:spPr>
       </p:pic>
+      <p:sp>
+        <p:nvSpPr>
+          <p:cNvPr id="4" name="TextBox 3">
+            <a:extLst>
+              <a:ext uri="{FF2B5EF4-FFF2-40B4-BE49-F238E27FC236}">
+                <a16:creationId xmlns:a16="http://schemas.microsoft.com/office/drawing/2014/main" id="{D3008A4D-5BF3-9B86-052C-E81F9A1C2902}"/>
+              </a:ext>
+            </a:extLst>
+          </p:cNvPr>
+          <p:cNvSpPr txBox="1"/>
+          <p:nvPr/>
+        </p:nvSpPr>
+        <p:spPr>
+          <a:xfrm>
+            <a:off x="2580640" y="3059668"/>
+            <a:ext cx="2418080" cy="369332"/>
+          </a:xfrm>
+          <a:prstGeom prst="rect">
+            <a:avLst/>
+          </a:prstGeom>
+          <a:noFill/>
+        </p:spPr>
+        <p:txBody>
+          <a:bodyPr wrap="square" rtlCol="0">
+            <a:spAutoFit/>
+          </a:bodyPr>
+          <a:lstStyle/>
+          <a:p>
+            <a:r>
+              <a:rPr lang="en-US" dirty="0">
+                <a:solidFill>
+                  <a:schemeClr val="bg1"/>
+                </a:solidFill>
+              </a:rPr>
+              <a:t>[</a:t>
+            </a:r>
+            <a:r>
+              <a:rPr lang="uk-UA" dirty="0">
+                <a:solidFill>
+                  <a:schemeClr val="bg1"/>
+                </a:solidFill>
+              </a:rPr>
+              <a:t>тут має бути фото</a:t>
+            </a:r>
+            <a:r>
+              <a:rPr lang="en-US" dirty="0">
+                <a:solidFill>
+                  <a:schemeClr val="bg1"/>
+                </a:solidFill>
+              </a:rPr>
+              <a:t>]</a:t>
+            </a:r>
+            <a:endParaRPr lang="en-UA" dirty="0">
+              <a:solidFill>
+                <a:schemeClr val="bg1"/>
+              </a:solidFill>
+            </a:endParaRPr>
+          </a:p>
+        </p:txBody>
+      </p:sp>
     </p:spTree>
     <p:extLst>
       <p:ext uri="{BB962C8B-B14F-4D97-AF65-F5344CB8AC3E}">
@@ -8056,6 +8146,36 @@
           <a:xfrm>
             <a:off x="7074328" y="4211483"/>
             <a:ext cx="2723046" cy="1524906"/>
+          </a:xfrm>
+          <a:prstGeom prst="rect">
+            <a:avLst/>
+          </a:prstGeom>
+        </p:spPr>
+      </p:pic>
+      <p:pic>
+        <p:nvPicPr>
+          <p:cNvPr id="2" name="Picture 1" descr="A yellow and green corner&#10;&#10;Description automatically generated">
+            <a:extLst>
+              <a:ext uri="{FF2B5EF4-FFF2-40B4-BE49-F238E27FC236}">
+                <a16:creationId xmlns:a16="http://schemas.microsoft.com/office/drawing/2014/main" id="{2A4BA901-5C31-09B0-5CF0-AD45803C84A6}"/>
+              </a:ext>
+            </a:extLst>
+          </p:cNvPr>
+          <p:cNvPicPr>
+            <a:picLocks noChangeAspect="1"/>
+          </p:cNvPicPr>
+          <p:nvPr/>
+        </p:nvPicPr>
+        <p:blipFill>
+          <a:blip r:embed="rId7"/>
+          <a:stretch>
+            <a:fillRect/>
+          </a:stretch>
+        </p:blipFill>
+        <p:spPr>
+          <a:xfrm>
+            <a:off x="11656911" y="6327267"/>
+            <a:ext cx="436029" cy="442697"/>
           </a:xfrm>
           <a:prstGeom prst="rect">
             <a:avLst/>
@@ -8744,6 +8864,36 @@
           </a:p>
         </p:txBody>
       </p:sp>
+      <p:pic>
+        <p:nvPicPr>
+          <p:cNvPr id="2" name="Picture 1" descr="A yellow and green corner&#10;&#10;Description automatically generated">
+            <a:extLst>
+              <a:ext uri="{FF2B5EF4-FFF2-40B4-BE49-F238E27FC236}">
+                <a16:creationId xmlns:a16="http://schemas.microsoft.com/office/drawing/2014/main" id="{A691AAA1-5DEE-DBC2-891B-6DFFC8D4D782}"/>
+              </a:ext>
+            </a:extLst>
+          </p:cNvPr>
+          <p:cNvPicPr>
+            <a:picLocks noChangeAspect="1"/>
+          </p:cNvPicPr>
+          <p:nvPr/>
+        </p:nvPicPr>
+        <p:blipFill>
+          <a:blip r:embed="rId3"/>
+          <a:stretch>
+            <a:fillRect/>
+          </a:stretch>
+        </p:blipFill>
+        <p:spPr>
+          <a:xfrm>
+            <a:off x="11656911" y="6327267"/>
+            <a:ext cx="436029" cy="442697"/>
+          </a:xfrm>
+          <a:prstGeom prst="rect">
+            <a:avLst/>
+          </a:prstGeom>
+        </p:spPr>
+      </p:pic>
     </p:spTree>
     <p:extLst>
       <p:ext uri="{BB962C8B-B14F-4D97-AF65-F5344CB8AC3E}">
@@ -9056,6 +9206,36 @@
           </a:prstGeom>
         </p:spPr>
       </p:pic>
+      <p:pic>
+        <p:nvPicPr>
+          <p:cNvPr id="2" name="Picture 1" descr="A yellow and green corner&#10;&#10;Description automatically generated">
+            <a:extLst>
+              <a:ext uri="{FF2B5EF4-FFF2-40B4-BE49-F238E27FC236}">
+                <a16:creationId xmlns:a16="http://schemas.microsoft.com/office/drawing/2014/main" id="{6095589D-CEB7-BED8-940D-B4F6142F2A32}"/>
+              </a:ext>
+            </a:extLst>
+          </p:cNvPr>
+          <p:cNvPicPr>
+            <a:picLocks noChangeAspect="1"/>
+          </p:cNvPicPr>
+          <p:nvPr/>
+        </p:nvPicPr>
+        <p:blipFill>
+          <a:blip r:embed="rId3"/>
+          <a:stretch>
+            <a:fillRect/>
+          </a:stretch>
+        </p:blipFill>
+        <p:spPr>
+          <a:xfrm>
+            <a:off x="11656911" y="6327267"/>
+            <a:ext cx="436029" cy="442697"/>
+          </a:xfrm>
+          <a:prstGeom prst="rect">
+            <a:avLst/>
+          </a:prstGeom>
+        </p:spPr>
+      </p:pic>
     </p:spTree>
     <p:extLst>
       <p:ext uri="{BB962C8B-B14F-4D97-AF65-F5344CB8AC3E}">
@@ -9900,6 +10080,36 @@
           </a:p>
         </p:txBody>
       </p:sp>
+      <p:pic>
+        <p:nvPicPr>
+          <p:cNvPr id="2" name="Picture 1" descr="A yellow and green corner&#10;&#10;Description automatically generated">
+            <a:extLst>
+              <a:ext uri="{FF2B5EF4-FFF2-40B4-BE49-F238E27FC236}">
+                <a16:creationId xmlns:a16="http://schemas.microsoft.com/office/drawing/2014/main" id="{7EB4F180-E835-913C-2842-526728C1E990}"/>
+              </a:ext>
+            </a:extLst>
+          </p:cNvPr>
+          <p:cNvPicPr>
+            <a:picLocks noChangeAspect="1"/>
+          </p:cNvPicPr>
+          <p:nvPr/>
+        </p:nvPicPr>
+        <p:blipFill>
+          <a:blip r:embed="rId2"/>
+          <a:stretch>
+            <a:fillRect/>
+          </a:stretch>
+        </p:blipFill>
+        <p:spPr>
+          <a:xfrm>
+            <a:off x="11656911" y="6327267"/>
+            <a:ext cx="436029" cy="442697"/>
+          </a:xfrm>
+          <a:prstGeom prst="rect">
+            <a:avLst/>
+          </a:prstGeom>
+        </p:spPr>
+      </p:pic>
     </p:spTree>
     <p:extLst>
       <p:ext uri="{BB962C8B-B14F-4D97-AF65-F5344CB8AC3E}">

</xml_diff>